<commit_message>
docs: clarify single-speaker demo and reward box
</commit_message>
<xml_diff>
--- a/docs/presentation/X5_Checkpoint_Своя_Пятёрочка_финальная.pptx
+++ b/docs/presentation/X5_Checkpoint_Своя_Пятёрочка_финальная.pptx
@@ -10,8 +10,8 @@
   <p:sldIdLst>
     <p:sldId id="256" r:id="rId2"/>
     <p:sldId id="257" r:id="rId3"/>
+    <p:sldId id="259" r:id="rId5"/>
     <p:sldId id="264" r:id="rId4"/>
-    <p:sldId id="259" r:id="rId5"/>
     <p:sldId id="266" r:id="rId6"/>
     <p:sldId id="268" r:id="rId7"/>
     <p:sldId id="270" r:id="rId8"/>
@@ -1524,7 +1524,7 @@
                 <a:ea typeface="Arial"/>
                 <a:cs typeface="Arial"/>
               </a:rPr>
-              <a:t>Покупка → предмет. Четыре предмета → выбранная скидка.</a:t>
+              <a:t>Покупка → коробка → предмет. Четыре предмета → выбранная скидка.</a:t>
             </a:r>
           </a:p>
         </p:txBody>
@@ -5147,7 +5147,7 @@
                 <a:ea typeface="Arial"/>
                 <a:cs typeface="Arial"/>
               </a:rPr>
-              <a:t>Чек</a:t>
+              <a:t>Чек + коробка</a:t>
             </a:r>
           </a:p>
         </p:txBody>
@@ -5206,7 +5206,7 @@
                 <a:ea typeface="Arial"/>
                 <a:cs typeface="Arial"/>
               </a:rPr>
-              <a:t>2 награды</a:t>
+              <a:t>награда один раз</a:t>
             </a:r>
           </a:p>
         </p:txBody>

</xml_diff>